<commit_message>
still no slide content
</commit_message>
<xml_diff>
--- a/test/formatting-test.pptx
+++ b/test/formatting-test.pptx
@@ -489,7 +489,7 @@
                   <a:srgbClr val="000000"/>
                 </a:solidFill>
               </a:rPr>
-              <a:t/>
+              <a:t>Formatting Test</a:t>
             </a:r>
             <a:endParaRPr lang="en-US"/>
           </a:p>
@@ -521,7 +521,7 @@
                   <a:srgbClr val="000000"/>
                 </a:solidFill>
               </a:rPr>
-              <a:t/>
+              <a:t>ox-ppt</a:t>
             </a:r>
             <a:endParaRPr lang="en-US"/>
           </a:p>
@@ -613,7 +613,6 @@
             <a:r>
               <a:rPr sz="1800"/>
               <a:rPr b="1"/>
-              <a:rPr lang="en-US"/>
               <a:t>bold text</a:t>
             </a:r>
             <a:r>
@@ -624,7 +623,6 @@
             <a:r>
               <a:rPr sz="1800"/>
               <a:rPr i="1"/>
-              <a:rPr lang="en-US"/>
               <a:t>italic text</a:t>
             </a:r>
             <a:r>
@@ -635,7 +633,6 @@
             <a:r>
               <a:rPr sz="1800"/>
               <a:rPr u="sng"/>
-              <a:rPr lang="en-US"/>
               <a:t>underlined text</a:t>
             </a:r>
             <a:r>
@@ -656,14 +653,11 @@
             <a:r>
               <a:rPr sz="1800"/>
               <a:rPr b="1"/>
-              <a:rPr lang="en-US"/>
               <a:t>bold and </a:t>
             </a:r>
             <a:r>
               <a:rPr sz="1800"/>
               <a:rPr b="1"/>
-              <a:rPr i="1"/>
-              <a:rPr lang="en-US"/>
               <a:t>italic</a:t>
             </a:r>
             <a:r>
@@ -882,7 +876,6 @@
             <a:r>
               <a:rPr sz="1800"/>
               <a:rPr b="1"/>
-              <a:rPr lang="en-US"/>
               <a:t>bold</a:t>
             </a:r>
             <a:r>
@@ -893,7 +886,6 @@
             <a:r>
               <a:rPr sz="1800"/>
               <a:rPr i="1"/>
-              <a:rPr lang="en-US"/>
               <a:t>italic</a:t>
             </a:r>
             <a:r>
@@ -904,7 +896,6 @@
             <a:r>
               <a:rPr sz="1800"/>
               <a:rPr u="sng"/>
-              <a:rPr lang="en-US"/>
               <a:t>underline</a:t>
             </a:r>
             <a:r>
@@ -932,20 +923,16 @@
             <a:r>
               <a:rPr sz="1800"/>
               <a:rPr b="1"/>
-              <a:rPr lang="en-US"/>
               <a:t>This whole sentence is bold, with </a:t>
             </a:r>
             <a:r>
               <a:rPr sz="1800"/>
               <a:rPr b="1"/>
-              <a:rPr i="1"/>
-              <a:rPr lang="en-US"/>
               <a:t>italic inside</a:t>
             </a:r>
             <a:r>
               <a:rPr sz="1800"/>
               <a:rPr b="1"/>
-              <a:rPr lang="en-US"/>
               <a:t>it.</a:t>
             </a:r>
             <a:r>
@@ -961,20 +948,16 @@
             <a:r>
               <a:rPr sz="1800"/>
               <a:rPr i="1"/>
-              <a:rPr lang="en-US"/>
               <a:t>This whole sentence is italic, with </a:t>
             </a:r>
             <a:r>
               <a:rPr sz="1800"/>
               <a:rPr i="1"/>
-              <a:rPr b="1"/>
-              <a:rPr lang="en-US"/>
               <a:t>bold inside</a:t>
             </a:r>
             <a:r>
               <a:rPr sz="1800"/>
               <a:rPr i="1"/>
-              <a:rPr lang="en-US"/>
               <a:t>it.</a:t>
             </a:r>
             <a:r>

</xml_diff>